<commit_message>
Matndagi xatolarni tuzatish: qisqartmalar, glossariy va savol-javob
Reja sarlavhalari REJA ro'yxatidan olinadi (SHHV, UZO, UPS, FV, 2FA, YO'R kichik harfga aylanmaydi).
Glossariyga faqat «Atama — ta'rif» bandlari kiradi; «Talab:» va «Qadam.» bandlari savol-javobga mos savol bilan o'tadi.
Savol-javobda takroriy javoblar va ikkilangan qo'shtirnoqlar olib tashlandi; taqdimot fayllari qayta yaratildi.

Co-Authored-By: Claude Opus 5.5 <noreply@anthropic.com>
</commit_message>
<xml_diff>
--- a/sayt/media/resources/2026/10/mehnat-muhofazasi-01-mavzu.pptx
+++ b/sayt/media/resources/2026/10/mehnat-muhofazasi-01-mavzu.pptx
@@ -12098,11 +12098,11 @@
         <p:spPr>
           <a:xfrm>
             <a:off x="731520" y="1645158"/>
-            <a:ext cx="5204307" cy="1310894"/>
+            <a:ext cx="10728655" cy="2080641"/>
           </a:xfrm>
           <a:prstGeom prst="roundRect">
             <a:avLst>
-              <a:gd name="adj" fmla="val 5580"/>
+              <a:gd name="adj" fmla="val 3515"/>
             </a:avLst>
           </a:prstGeom>
           <a:solidFill>
@@ -12146,7 +12146,7 @@
         <p:spPr>
           <a:xfrm>
             <a:off x="731520" y="1645158"/>
-            <a:ext cx="73152" cy="1310894"/>
+            <a:ext cx="73152" cy="2080641"/>
           </a:xfrm>
           <a:prstGeom prst="rect">
             <a:avLst/>
@@ -12190,7 +12190,7 @@
         <p:spPr>
           <a:xfrm>
             <a:off x="1005840" y="1809750"/>
-            <a:ext cx="4936991" cy="294004"/>
+            <a:ext cx="10682313" cy="367029"/>
           </a:xfrm>
           <a:prstGeom prst="rect">
             <a:avLst/>
@@ -12205,371 +12205,11 @@
           <a:p>
             <a:pPr algn="l">
               <a:lnSpc>
-                <a:spcPts val="1954"/>
+                <a:spcPts val="2529"/>
               </a:lnSpc>
             </a:pPr>
             <a:r>
-              <a:rPr sz="1700" b="1">
-                <a:solidFill>
-                  <a:srgbClr val="1B2A4A"/>
-                </a:solidFill>
-                <a:latin typeface="Georgia"/>
-              </a:rPr>
-              <a:t>Blik (yaltirash)</a:t>
-            </a:r>
-          </a:p>
-        </p:txBody>
-      </p:sp>
-      <p:sp>
-        <p:nvSpPr>
-          <p:cNvPr id="40" name="TextBox 39"/>
-          <p:cNvSpPr txBox="1"/>
-          <p:nvPr/>
-        </p:nvSpPr>
-        <p:spPr>
-          <a:xfrm>
-            <a:off x="1005840" y="2149475"/>
-            <a:ext cx="4936991" cy="508000"/>
-          </a:xfrm>
-          <a:prstGeom prst="rect">
-            <a:avLst/>
-          </a:prstGeom>
-          <a:noFill/>
-        </p:spPr>
-        <p:txBody>
-          <a:bodyPr wrap="square" lIns="0" rIns="0" tIns="0" bIns="0" anchor="t">
-            <a:spAutoFit/>
-          </a:bodyPr>
-          <a:lstStyle/>
-          <a:p>
-            <a:pPr algn="l">
-              <a:lnSpc>
-                <a:spcPts val="1820"/>
-              </a:lnSpc>
-            </a:pPr>
-            <a:r>
-              <a:rPr sz="1400" b="0">
-                <a:solidFill>
-                  <a:srgbClr val="3A4560"/>
-                </a:solidFill>
-                <a:latin typeface="Segoe UI"/>
-              </a:rPr>
-              <a:t>Monitor ekranida deraza yoki chiroqdan aks paydo</a:t>
-            </a:r>
-            <a:br/>
-            <a:r>
-              <a:rPr sz="1400" b="0">
-                <a:solidFill>
-                  <a:srgbClr val="3A4560"/>
-                </a:solidFill>
-                <a:latin typeface="Segoe UI"/>
-              </a:rPr>
-              <a:t>bo‘lmasligi lozim, chunki u ko‘zni qo‘shimcha zo‘riqtiradi.</a:t>
-            </a:r>
-          </a:p>
-        </p:txBody>
-      </p:sp>
-      <p:sp>
-        <p:nvSpPr>
-          <p:cNvPr id="41" name="Rounded Rectangle 40"/>
-          <p:cNvSpPr/>
-          <p:nvPr/>
-        </p:nvSpPr>
-        <p:spPr>
-          <a:xfrm>
-            <a:off x="6255867" y="1645158"/>
-            <a:ext cx="5204307" cy="1310894"/>
-          </a:xfrm>
-          <a:prstGeom prst="roundRect">
-            <a:avLst>
-              <a:gd name="adj" fmla="val 5580"/>
-            </a:avLst>
-          </a:prstGeom>
-          <a:solidFill>
-            <a:srgbClr val="FBF6EC"/>
-          </a:solidFill>
-          <a:ln w="12700">
-            <a:solidFill>
-              <a:srgbClr val="D8C8AE"/>
-            </a:solidFill>
-          </a:ln>
-          <a:effectLst/>
-        </p:spPr>
-        <p:style>
-          <a:lnRef idx="1">
-            <a:schemeClr val="accent1"/>
-          </a:lnRef>
-          <a:fillRef idx="3">
-            <a:schemeClr val="accent1"/>
-          </a:fillRef>
-          <a:effectRef idx="2">
-            <a:schemeClr val="accent1"/>
-          </a:effectRef>
-          <a:fontRef idx="minor">
-            <a:schemeClr val="lt1"/>
-          </a:fontRef>
-        </p:style>
-        <p:txBody>
-          <a:bodyPr rtlCol="0" anchor="ctr"/>
-          <a:lstStyle/>
-          <a:p>
-            <a:pPr algn="ctr"/>
-          </a:p>
-        </p:txBody>
-      </p:sp>
-      <p:sp>
-        <p:nvSpPr>
-          <p:cNvPr id="42" name="Rectangle 41"/>
-          <p:cNvSpPr/>
-          <p:nvPr/>
-        </p:nvSpPr>
-        <p:spPr>
-          <a:xfrm>
-            <a:off x="6255867" y="1645158"/>
-            <a:ext cx="73152" cy="1310894"/>
-          </a:xfrm>
-          <a:prstGeom prst="rect">
-            <a:avLst/>
-          </a:prstGeom>
-          <a:solidFill>
-            <a:srgbClr val="C2562D"/>
-          </a:solidFill>
-          <a:ln>
-            <a:noFill/>
-          </a:ln>
-          <a:effectLst/>
-        </p:spPr>
-        <p:style>
-          <a:lnRef idx="1">
-            <a:schemeClr val="accent1"/>
-          </a:lnRef>
-          <a:fillRef idx="3">
-            <a:schemeClr val="accent1"/>
-          </a:fillRef>
-          <a:effectRef idx="2">
-            <a:schemeClr val="accent1"/>
-          </a:effectRef>
-          <a:fontRef idx="minor">
-            <a:schemeClr val="lt1"/>
-          </a:fontRef>
-        </p:style>
-        <p:txBody>
-          <a:bodyPr rtlCol="0" anchor="ctr"/>
-          <a:lstStyle/>
-          <a:p>
-            <a:pPr algn="ctr"/>
-          </a:p>
-        </p:txBody>
-      </p:sp>
-      <p:sp>
-        <p:nvSpPr>
-          <p:cNvPr id="43" name="TextBox 42"/>
-          <p:cNvSpPr txBox="1"/>
-          <p:nvPr/>
-        </p:nvSpPr>
-        <p:spPr>
-          <a:xfrm>
-            <a:off x="6530187" y="1809750"/>
-            <a:ext cx="4936991" cy="308609"/>
-          </a:xfrm>
-          <a:prstGeom prst="rect">
-            <a:avLst/>
-          </a:prstGeom>
-          <a:noFill/>
-        </p:spPr>
-        <p:txBody>
-          <a:bodyPr wrap="square" lIns="0" rIns="0" tIns="0" bIns="0" anchor="t">
-            <a:spAutoFit/>
-          </a:bodyPr>
-          <a:lstStyle/>
-          <a:p>
-            <a:pPr algn="l">
-              <a:lnSpc>
-                <a:spcPts val="2070"/>
-              </a:lnSpc>
-            </a:pPr>
-            <a:r>
-              <a:rPr sz="1800" b="1">
-                <a:solidFill>
-                  <a:srgbClr val="1B2A4A"/>
-                </a:solidFill>
-                <a:latin typeface="Georgia"/>
-              </a:rPr>
-              <a:t>Davriy tozalash</a:t>
-            </a:r>
-          </a:p>
-        </p:txBody>
-      </p:sp>
-      <p:sp>
-        <p:nvSpPr>
-          <p:cNvPr id="44" name="TextBox 43"/>
-          <p:cNvSpPr txBox="1"/>
-          <p:nvPr/>
-        </p:nvSpPr>
-        <p:spPr>
-          <a:xfrm>
-            <a:off x="6530187" y="2164080"/>
-            <a:ext cx="4936991" cy="541020"/>
-          </a:xfrm>
-          <a:prstGeom prst="rect">
-            <a:avLst/>
-          </a:prstGeom>
-          <a:noFill/>
-        </p:spPr>
-        <p:txBody>
-          <a:bodyPr wrap="square" lIns="0" rIns="0" tIns="0" bIns="0" anchor="t">
-            <a:spAutoFit/>
-          </a:bodyPr>
-          <a:lstStyle/>
-          <a:p>
-            <a:pPr algn="l">
-              <a:lnSpc>
-                <a:spcPts val="1950"/>
-              </a:lnSpc>
-            </a:pPr>
-            <a:r>
-              <a:rPr sz="1500" b="0">
-                <a:solidFill>
-                  <a:srgbClr val="3A4560"/>
-                </a:solidFill>
-                <a:latin typeface="Segoe UI"/>
-              </a:rPr>
-              <a:t>Oyiga kamida bir marta dezinfeksiyalovchi vositalar</a:t>
-            </a:r>
-            <a:br/>
-            <a:r>
-              <a:rPr sz="1500" b="0">
-                <a:solidFill>
-                  <a:srgbClr val="3A4560"/>
-                </a:solidFill>
-                <a:latin typeface="Segoe UI"/>
-              </a:rPr>
-              <a:t>yordamida umumiy tozalash (sanitariya kuni) o‘tkaziladi.</a:t>
-            </a:r>
-          </a:p>
-        </p:txBody>
-      </p:sp>
-      <p:sp>
-        <p:nvSpPr>
-          <p:cNvPr id="45" name="Rounded Rectangle 44"/>
-          <p:cNvSpPr/>
-          <p:nvPr/>
-        </p:nvSpPr>
-        <p:spPr>
-          <a:xfrm>
-            <a:off x="731520" y="3184652"/>
-            <a:ext cx="5204307" cy="1310894"/>
-          </a:xfrm>
-          <a:prstGeom prst="roundRect">
-            <a:avLst>
-              <a:gd name="adj" fmla="val 5580"/>
-            </a:avLst>
-          </a:prstGeom>
-          <a:solidFill>
-            <a:srgbClr val="FBF6EC"/>
-          </a:solidFill>
-          <a:ln w="12700">
-            <a:solidFill>
-              <a:srgbClr val="D8C8AE"/>
-            </a:solidFill>
-          </a:ln>
-          <a:effectLst/>
-        </p:spPr>
-        <p:style>
-          <a:lnRef idx="1">
-            <a:schemeClr val="accent1"/>
-          </a:lnRef>
-          <a:fillRef idx="3">
-            <a:schemeClr val="accent1"/>
-          </a:fillRef>
-          <a:effectRef idx="2">
-            <a:schemeClr val="accent1"/>
-          </a:effectRef>
-          <a:fontRef idx="minor">
-            <a:schemeClr val="lt1"/>
-          </a:fontRef>
-        </p:style>
-        <p:txBody>
-          <a:bodyPr rtlCol="0" anchor="ctr"/>
-          <a:lstStyle/>
-          <a:p>
-            <a:pPr algn="ctr"/>
-          </a:p>
-        </p:txBody>
-      </p:sp>
-      <p:sp>
-        <p:nvSpPr>
-          <p:cNvPr id="46" name="Rectangle 45"/>
-          <p:cNvSpPr/>
-          <p:nvPr/>
-        </p:nvSpPr>
-        <p:spPr>
-          <a:xfrm>
-            <a:off x="731520" y="3184652"/>
-            <a:ext cx="73152" cy="1310894"/>
-          </a:xfrm>
-          <a:prstGeom prst="rect">
-            <a:avLst/>
-          </a:prstGeom>
-          <a:solidFill>
-            <a:srgbClr val="C2562D"/>
-          </a:solidFill>
-          <a:ln>
-            <a:noFill/>
-          </a:ln>
-          <a:effectLst/>
-        </p:spPr>
-        <p:style>
-          <a:lnRef idx="1">
-            <a:schemeClr val="accent1"/>
-          </a:lnRef>
-          <a:fillRef idx="3">
-            <a:schemeClr val="accent1"/>
-          </a:fillRef>
-          <a:effectRef idx="2">
-            <a:schemeClr val="accent1"/>
-          </a:effectRef>
-          <a:fontRef idx="minor">
-            <a:schemeClr val="lt1"/>
-          </a:fontRef>
-        </p:style>
-        <p:txBody>
-          <a:bodyPr rtlCol="0" anchor="ctr"/>
-          <a:lstStyle/>
-          <a:p>
-            <a:pPr algn="ctr"/>
-          </a:p>
-        </p:txBody>
-      </p:sp>
-      <p:sp>
-        <p:nvSpPr>
-          <p:cNvPr id="47" name="TextBox 46"/>
-          <p:cNvSpPr txBox="1"/>
-          <p:nvPr/>
-        </p:nvSpPr>
-        <p:spPr>
-          <a:xfrm>
-            <a:off x="1005840" y="3349244"/>
-            <a:ext cx="4936991" cy="294004"/>
-          </a:xfrm>
-          <a:prstGeom prst="rect">
-            <a:avLst/>
-          </a:prstGeom>
-          <a:noFill/>
-        </p:spPr>
-        <p:txBody>
-          <a:bodyPr wrap="square" lIns="0" rIns="0" tIns="0" bIns="0" anchor="t">
-            <a:spAutoFit/>
-          </a:bodyPr>
-          <a:lstStyle/>
-          <a:p>
-            <a:pPr algn="l">
-              <a:lnSpc>
-                <a:spcPts val="1954"/>
-              </a:lnSpc>
-            </a:pPr>
-            <a:r>
-              <a:rPr sz="1700" b="1">
+              <a:rPr sz="2200" b="1">
                 <a:solidFill>
                   <a:srgbClr val="1B2A4A"/>
                 </a:solidFill>
@@ -12582,14 +12222,14 @@
       </p:sp>
       <p:sp>
         <p:nvSpPr>
-          <p:cNvPr id="48" name="TextBox 47"/>
+          <p:cNvPr id="40" name="TextBox 39"/>
           <p:cNvSpPr txBox="1"/>
           <p:nvPr/>
         </p:nvSpPr>
         <p:spPr>
           <a:xfrm>
-            <a:off x="1005840" y="3688968"/>
-            <a:ext cx="4936991" cy="739140"/>
+            <a:off x="1005840" y="2222500"/>
+            <a:ext cx="10682313" cy="673100"/>
           </a:xfrm>
           <a:prstGeom prst="rect">
             <a:avLst/>
@@ -12604,587 +12244,197 @@
           <a:p>
             <a:pPr algn="l">
               <a:lnSpc>
-                <a:spcPts val="1820"/>
+                <a:spcPts val="2470"/>
               </a:lnSpc>
             </a:pPr>
             <a:r>
-              <a:rPr sz="1400" b="0">
+              <a:rPr sz="1900" b="0">
                 <a:solidFill>
                   <a:srgbClr val="3A4560"/>
                 </a:solidFill>
                 <a:latin typeface="Segoe UI"/>
               </a:rPr>
-              <a:t>Tashqi muhit va mehnat sharoitlarining inson salomatligiga</a:t>
+              <a:t>Tashqi muhit va mehnat sharoitlarining inson salomatligiga ta’sirini o‘rganuvchi, sog‘liqni</a:t>
             </a:r>
             <a:br/>
             <a:r>
-              <a:rPr sz="1400" b="0">
+              <a:rPr sz="1900" b="0">
                 <a:solidFill>
                   <a:srgbClr val="3A4560"/>
                 </a:solidFill>
                 <a:latin typeface="Segoe UI"/>
               </a:rPr>
-              <a:t>ta’sirini o‘rganuvchi, sog‘liqni saqlash va kasalliklarning</a:t>
+              <a:t>saqlash va kasalliklarning oldini olish qoidalarini…</a:t>
             </a:r>
-            <a:br/>
+          </a:p>
+        </p:txBody>
+      </p:sp>
+      <p:sp>
+        <p:nvSpPr>
+          <p:cNvPr id="41" name="Rounded Rectangle 40"/>
+          <p:cNvSpPr/>
+          <p:nvPr/>
+        </p:nvSpPr>
+        <p:spPr>
+          <a:xfrm>
+            <a:off x="731520" y="3954398"/>
+            <a:ext cx="10728655" cy="2080641"/>
+          </a:xfrm>
+          <a:prstGeom prst="roundRect">
+            <a:avLst>
+              <a:gd name="adj" fmla="val 3515"/>
+            </a:avLst>
+          </a:prstGeom>
+          <a:solidFill>
+            <a:srgbClr val="FBF6EC"/>
+          </a:solidFill>
+          <a:ln w="12700">
+            <a:solidFill>
+              <a:srgbClr val="D8C8AE"/>
+            </a:solidFill>
+          </a:ln>
+          <a:effectLst/>
+        </p:spPr>
+        <p:style>
+          <a:lnRef idx="1">
+            <a:schemeClr val="accent1"/>
+          </a:lnRef>
+          <a:fillRef idx="3">
+            <a:schemeClr val="accent1"/>
+          </a:fillRef>
+          <a:effectRef idx="2">
+            <a:schemeClr val="accent1"/>
+          </a:effectRef>
+          <a:fontRef idx="minor">
+            <a:schemeClr val="lt1"/>
+          </a:fontRef>
+        </p:style>
+        <p:txBody>
+          <a:bodyPr rtlCol="0" anchor="ctr"/>
+          <a:lstStyle/>
+          <a:p>
+            <a:pPr algn="ctr"/>
+          </a:p>
+        </p:txBody>
+      </p:sp>
+      <p:sp>
+        <p:nvSpPr>
+          <p:cNvPr id="42" name="Rectangle 41"/>
+          <p:cNvSpPr/>
+          <p:nvPr/>
+        </p:nvSpPr>
+        <p:spPr>
+          <a:xfrm>
+            <a:off x="731520" y="3954398"/>
+            <a:ext cx="73152" cy="2080641"/>
+          </a:xfrm>
+          <a:prstGeom prst="rect">
+            <a:avLst/>
+          </a:prstGeom>
+          <a:solidFill>
+            <a:srgbClr val="C2562D"/>
+          </a:solidFill>
+          <a:ln>
+            <a:noFill/>
+          </a:ln>
+          <a:effectLst/>
+        </p:spPr>
+        <p:style>
+          <a:lnRef idx="1">
+            <a:schemeClr val="accent1"/>
+          </a:lnRef>
+          <a:fillRef idx="3">
+            <a:schemeClr val="accent1"/>
+          </a:fillRef>
+          <a:effectRef idx="2">
+            <a:schemeClr val="accent1"/>
+          </a:effectRef>
+          <a:fontRef idx="minor">
+            <a:schemeClr val="lt1"/>
+          </a:fontRef>
+        </p:style>
+        <p:txBody>
+          <a:bodyPr rtlCol="0" anchor="ctr"/>
+          <a:lstStyle/>
+          <a:p>
+            <a:pPr algn="ctr"/>
+          </a:p>
+        </p:txBody>
+      </p:sp>
+      <p:sp>
+        <p:nvSpPr>
+          <p:cNvPr id="43" name="TextBox 42"/>
+          <p:cNvSpPr txBox="1"/>
+          <p:nvPr/>
+        </p:nvSpPr>
+        <p:spPr>
+          <a:xfrm>
+            <a:off x="1005840" y="4118990"/>
+            <a:ext cx="10682313" cy="367029"/>
+          </a:xfrm>
+          <a:prstGeom prst="rect">
+            <a:avLst/>
+          </a:prstGeom>
+          <a:noFill/>
+        </p:spPr>
+        <p:txBody>
+          <a:bodyPr wrap="square" lIns="0" rIns="0" tIns="0" bIns="0" anchor="t">
+            <a:spAutoFit/>
+          </a:bodyPr>
+          <a:lstStyle/>
+          <a:p>
+            <a:pPr algn="l">
+              <a:lnSpc>
+                <a:spcPts val="2529"/>
+              </a:lnSpc>
+            </a:pPr>
             <a:r>
-              <a:rPr sz="1400" b="0">
+              <a:rPr sz="2200" b="1">
+                <a:solidFill>
+                  <a:srgbClr val="1B2A4A"/>
+                </a:solidFill>
+                <a:latin typeface="Georgia"/>
+              </a:rPr>
+              <a:t>Mikroiqlim</a:t>
+            </a:r>
+          </a:p>
+        </p:txBody>
+      </p:sp>
+      <p:sp>
+        <p:nvSpPr>
+          <p:cNvPr id="44" name="TextBox 43"/>
+          <p:cNvSpPr txBox="1"/>
+          <p:nvPr/>
+        </p:nvSpPr>
+        <p:spPr>
+          <a:xfrm>
+            <a:off x="1005840" y="4531740"/>
+            <a:ext cx="10682313" cy="359410"/>
+          </a:xfrm>
+          <a:prstGeom prst="rect">
+            <a:avLst/>
+          </a:prstGeom>
+          <a:noFill/>
+        </p:spPr>
+        <p:txBody>
+          <a:bodyPr wrap="square" lIns="0" rIns="0" tIns="0" bIns="0" anchor="t">
+            <a:spAutoFit/>
+          </a:bodyPr>
+          <a:lstStyle/>
+          <a:p>
+            <a:pPr algn="l">
+              <a:lnSpc>
+                <a:spcPts val="2470"/>
+              </a:lnSpc>
+            </a:pPr>
+            <a:r>
+              <a:rPr sz="1900" b="0">
                 <a:solidFill>
                   <a:srgbClr val="3A4560"/>
                 </a:solidFill>
                 <a:latin typeface="Segoe UI"/>
               </a:rPr>
-              <a:t>oldini olish qoidalarini…</a:t>
-            </a:r>
-          </a:p>
-        </p:txBody>
-      </p:sp>
-      <p:sp>
-        <p:nvSpPr>
-          <p:cNvPr id="49" name="Rounded Rectangle 48"/>
-          <p:cNvSpPr/>
-          <p:nvPr/>
-        </p:nvSpPr>
-        <p:spPr>
-          <a:xfrm>
-            <a:off x="6255867" y="3184652"/>
-            <a:ext cx="5204307" cy="1310894"/>
-          </a:xfrm>
-          <a:prstGeom prst="roundRect">
-            <a:avLst>
-              <a:gd name="adj" fmla="val 5580"/>
-            </a:avLst>
-          </a:prstGeom>
-          <a:solidFill>
-            <a:srgbClr val="FBF6EC"/>
-          </a:solidFill>
-          <a:ln w="12700">
-            <a:solidFill>
-              <a:srgbClr val="D8C8AE"/>
-            </a:solidFill>
-          </a:ln>
-          <a:effectLst/>
-        </p:spPr>
-        <p:style>
-          <a:lnRef idx="1">
-            <a:schemeClr val="accent1"/>
-          </a:lnRef>
-          <a:fillRef idx="3">
-            <a:schemeClr val="accent1"/>
-          </a:fillRef>
-          <a:effectRef idx="2">
-            <a:schemeClr val="accent1"/>
-          </a:effectRef>
-          <a:fontRef idx="minor">
-            <a:schemeClr val="lt1"/>
-          </a:fontRef>
-        </p:style>
-        <p:txBody>
-          <a:bodyPr rtlCol="0" anchor="ctr"/>
-          <a:lstStyle/>
-          <a:p>
-            <a:pPr algn="ctr"/>
-          </a:p>
-        </p:txBody>
-      </p:sp>
-      <p:sp>
-        <p:nvSpPr>
-          <p:cNvPr id="50" name="Rectangle 49"/>
-          <p:cNvSpPr/>
-          <p:nvPr/>
-        </p:nvSpPr>
-        <p:spPr>
-          <a:xfrm>
-            <a:off x="6255867" y="3184652"/>
-            <a:ext cx="73152" cy="1310894"/>
-          </a:xfrm>
-          <a:prstGeom prst="rect">
-            <a:avLst/>
-          </a:prstGeom>
-          <a:solidFill>
-            <a:srgbClr val="C2562D"/>
-          </a:solidFill>
-          <a:ln>
-            <a:noFill/>
-          </a:ln>
-          <a:effectLst/>
-        </p:spPr>
-        <p:style>
-          <a:lnRef idx="1">
-            <a:schemeClr val="accent1"/>
-          </a:lnRef>
-          <a:fillRef idx="3">
-            <a:schemeClr val="accent1"/>
-          </a:fillRef>
-          <a:effectRef idx="2">
-            <a:schemeClr val="accent1"/>
-          </a:effectRef>
-          <a:fontRef idx="minor">
-            <a:schemeClr val="lt1"/>
-          </a:fontRef>
-        </p:style>
-        <p:txBody>
-          <a:bodyPr rtlCol="0" anchor="ctr"/>
-          <a:lstStyle/>
-          <a:p>
-            <a:pPr algn="ctr"/>
-          </a:p>
-        </p:txBody>
-      </p:sp>
-      <p:sp>
-        <p:nvSpPr>
-          <p:cNvPr id="51" name="TextBox 50"/>
-          <p:cNvSpPr txBox="1"/>
-          <p:nvPr/>
-        </p:nvSpPr>
-        <p:spPr>
-          <a:xfrm>
-            <a:off x="6530187" y="3349244"/>
-            <a:ext cx="4936991" cy="294004"/>
-          </a:xfrm>
-          <a:prstGeom prst="rect">
-            <a:avLst/>
-          </a:prstGeom>
-          <a:noFill/>
-        </p:spPr>
-        <p:txBody>
-          <a:bodyPr wrap="square" lIns="0" rIns="0" tIns="0" bIns="0" anchor="t">
-            <a:spAutoFit/>
-          </a:bodyPr>
-          <a:lstStyle/>
-          <a:p>
-            <a:pPr algn="l">
-              <a:lnSpc>
-                <a:spcPts val="1954"/>
-              </a:lnSpc>
-            </a:pPr>
-            <a:r>
-              <a:rPr sz="1700" b="1">
-                <a:solidFill>
-                  <a:srgbClr val="1B2A4A"/>
-                </a:solidFill>
-                <a:latin typeface="Georgia"/>
-              </a:rPr>
-              <a:t>Ish joyi gigiyenasi</a:t>
-            </a:r>
-          </a:p>
-        </p:txBody>
-      </p:sp>
-      <p:sp>
-        <p:nvSpPr>
-          <p:cNvPr id="52" name="TextBox 51"/>
-          <p:cNvSpPr txBox="1"/>
-          <p:nvPr/>
-        </p:nvSpPr>
-        <p:spPr>
-          <a:xfrm>
-            <a:off x="6530187" y="3688968"/>
-            <a:ext cx="4936991" cy="508000"/>
-          </a:xfrm>
-          <a:prstGeom prst="rect">
-            <a:avLst/>
-          </a:prstGeom>
-          <a:noFill/>
-        </p:spPr>
-        <p:txBody>
-          <a:bodyPr wrap="square" lIns="0" rIns="0" tIns="0" bIns="0" anchor="t">
-            <a:spAutoFit/>
-          </a:bodyPr>
-          <a:lstStyle/>
-          <a:p>
-            <a:pPr algn="l">
-              <a:lnSpc>
-                <a:spcPts val="1820"/>
-              </a:lnSpc>
-            </a:pPr>
-            <a:r>
-              <a:rPr sz="1400" b="0">
-                <a:solidFill>
-                  <a:srgbClr val="3A4560"/>
-                </a:solidFill>
-                <a:latin typeface="Segoe UI"/>
-              </a:rPr>
-              <a:t>Ish joyida ovqatlanmaslik va ichimlik ichmaslik; klaviatura,</a:t>
-            </a:r>
-            <a:br/>
-            <a:r>
-              <a:rPr sz="1400" b="0">
-                <a:solidFill>
-                  <a:srgbClr val="3A4560"/>
-                </a:solidFill>
-                <a:latin typeface="Segoe UI"/>
-              </a:rPr>
-              <a:t>sichqoncha va grafik planshetni muntazam artib turish.</a:t>
-            </a:r>
-          </a:p>
-        </p:txBody>
-      </p:sp>
-      <p:sp>
-        <p:nvSpPr>
-          <p:cNvPr id="53" name="Rounded Rectangle 52"/>
-          <p:cNvSpPr/>
-          <p:nvPr/>
-        </p:nvSpPr>
-        <p:spPr>
-          <a:xfrm>
-            <a:off x="731520" y="4724146"/>
-            <a:ext cx="5204307" cy="1310894"/>
-          </a:xfrm>
-          <a:prstGeom prst="roundRect">
-            <a:avLst>
-              <a:gd name="adj" fmla="val 5580"/>
-            </a:avLst>
-          </a:prstGeom>
-          <a:solidFill>
-            <a:srgbClr val="FBF6EC"/>
-          </a:solidFill>
-          <a:ln w="12700">
-            <a:solidFill>
-              <a:srgbClr val="D8C8AE"/>
-            </a:solidFill>
-          </a:ln>
-          <a:effectLst/>
-        </p:spPr>
-        <p:style>
-          <a:lnRef idx="1">
-            <a:schemeClr val="accent1"/>
-          </a:lnRef>
-          <a:fillRef idx="3">
-            <a:schemeClr val="accent1"/>
-          </a:fillRef>
-          <a:effectRef idx="2">
-            <a:schemeClr val="accent1"/>
-          </a:effectRef>
-          <a:fontRef idx="minor">
-            <a:schemeClr val="lt1"/>
-          </a:fontRef>
-        </p:style>
-        <p:txBody>
-          <a:bodyPr rtlCol="0" anchor="ctr"/>
-          <a:lstStyle/>
-          <a:p>
-            <a:pPr algn="ctr"/>
-          </a:p>
-        </p:txBody>
-      </p:sp>
-      <p:sp>
-        <p:nvSpPr>
-          <p:cNvPr id="54" name="Rectangle 53"/>
-          <p:cNvSpPr/>
-          <p:nvPr/>
-        </p:nvSpPr>
-        <p:spPr>
-          <a:xfrm>
-            <a:off x="731520" y="4724146"/>
-            <a:ext cx="73152" cy="1310894"/>
-          </a:xfrm>
-          <a:prstGeom prst="rect">
-            <a:avLst/>
-          </a:prstGeom>
-          <a:solidFill>
-            <a:srgbClr val="C2562D"/>
-          </a:solidFill>
-          <a:ln>
-            <a:noFill/>
-          </a:ln>
-          <a:effectLst/>
-        </p:spPr>
-        <p:style>
-          <a:lnRef idx="1">
-            <a:schemeClr val="accent1"/>
-          </a:lnRef>
-          <a:fillRef idx="3">
-            <a:schemeClr val="accent1"/>
-          </a:fillRef>
-          <a:effectRef idx="2">
-            <a:schemeClr val="accent1"/>
-          </a:effectRef>
-          <a:fontRef idx="minor">
-            <a:schemeClr val="lt1"/>
-          </a:fontRef>
-        </p:style>
-        <p:txBody>
-          <a:bodyPr rtlCol="0" anchor="ctr"/>
-          <a:lstStyle/>
-          <a:p>
-            <a:pPr algn="ctr"/>
-          </a:p>
-        </p:txBody>
-      </p:sp>
-      <p:sp>
-        <p:nvSpPr>
-          <p:cNvPr id="55" name="TextBox 54"/>
-          <p:cNvSpPr txBox="1"/>
-          <p:nvPr/>
-        </p:nvSpPr>
-        <p:spPr>
-          <a:xfrm>
-            <a:off x="1005840" y="4888738"/>
-            <a:ext cx="4936991" cy="294004"/>
-          </a:xfrm>
-          <a:prstGeom prst="rect">
-            <a:avLst/>
-          </a:prstGeom>
-          <a:noFill/>
-        </p:spPr>
-        <p:txBody>
-          <a:bodyPr wrap="square" lIns="0" rIns="0" tIns="0" bIns="0" anchor="t">
-            <a:spAutoFit/>
-          </a:bodyPr>
-          <a:lstStyle/>
-          <a:p>
-            <a:pPr algn="l">
-              <a:lnSpc>
-                <a:spcPts val="1954"/>
-              </a:lnSpc>
-            </a:pPr>
-            <a:r>
-              <a:rPr sz="1700" b="1">
-                <a:solidFill>
-                  <a:srgbClr val="1B2A4A"/>
-                </a:solidFill>
-                <a:latin typeface="Georgia"/>
-              </a:rPr>
-              <a:t>Jihozlar</a:t>
-            </a:r>
-          </a:p>
-        </p:txBody>
-      </p:sp>
-      <p:sp>
-        <p:nvSpPr>
-          <p:cNvPr id="56" name="TextBox 55"/>
-          <p:cNvSpPr txBox="1"/>
-          <p:nvPr/>
-        </p:nvSpPr>
-        <p:spPr>
-          <a:xfrm>
-            <a:off x="1005840" y="5228463"/>
-            <a:ext cx="4936991" cy="739140"/>
-          </a:xfrm>
-          <a:prstGeom prst="rect">
-            <a:avLst/>
-          </a:prstGeom>
-          <a:noFill/>
-        </p:spPr>
-        <p:txBody>
-          <a:bodyPr wrap="square" lIns="0" rIns="0" tIns="0" bIns="0" anchor="t">
-            <a:spAutoFit/>
-          </a:bodyPr>
-          <a:lstStyle/>
-          <a:p>
-            <a:pPr algn="l">
-              <a:lnSpc>
-                <a:spcPts val="1820"/>
-              </a:lnSpc>
-            </a:pPr>
-            <a:r>
-              <a:rPr sz="1400" b="0">
-                <a:solidFill>
-                  <a:srgbClr val="3A4560"/>
-                </a:solidFill>
-                <a:latin typeface="Segoe UI"/>
-              </a:rPr>
-              <a:t>Stul balandligi va suyanchig‘i sozlanadigan, stol yuzasi</a:t>
-            </a:r>
-            <a:br/>
-            <a:r>
-              <a:rPr sz="1400" b="0">
-                <a:solidFill>
-                  <a:srgbClr val="3A4560"/>
-                </a:solidFill>
-                <a:latin typeface="Segoe UI"/>
-              </a:rPr>
-              <a:t>monitor, klaviatura va grafik planshetni erkin joylashtirishga</a:t>
-            </a:r>
-            <a:br/>
-            <a:r>
-              <a:rPr sz="1400" b="0">
-                <a:solidFill>
-                  <a:srgbClr val="3A4560"/>
-                </a:solidFill>
-                <a:latin typeface="Segoe UI"/>
-              </a:rPr>
-              <a:t>yetarli bo‘lishi lozim.</a:t>
-            </a:r>
-          </a:p>
-        </p:txBody>
-      </p:sp>
-      <p:sp>
-        <p:nvSpPr>
-          <p:cNvPr id="57" name="Rounded Rectangle 56"/>
-          <p:cNvSpPr/>
-          <p:nvPr/>
-        </p:nvSpPr>
-        <p:spPr>
-          <a:xfrm>
-            <a:off x="6255867" y="4724146"/>
-            <a:ext cx="5204307" cy="1310894"/>
-          </a:xfrm>
-          <a:prstGeom prst="roundRect">
-            <a:avLst>
-              <a:gd name="adj" fmla="val 5580"/>
-            </a:avLst>
-          </a:prstGeom>
-          <a:solidFill>
-            <a:srgbClr val="FBF6EC"/>
-          </a:solidFill>
-          <a:ln w="12700">
-            <a:solidFill>
-              <a:srgbClr val="D8C8AE"/>
-            </a:solidFill>
-          </a:ln>
-          <a:effectLst/>
-        </p:spPr>
-        <p:style>
-          <a:lnRef idx="1">
-            <a:schemeClr val="accent1"/>
-          </a:lnRef>
-          <a:fillRef idx="3">
-            <a:schemeClr val="accent1"/>
-          </a:fillRef>
-          <a:effectRef idx="2">
-            <a:schemeClr val="accent1"/>
-          </a:effectRef>
-          <a:fontRef idx="minor">
-            <a:schemeClr val="lt1"/>
-          </a:fontRef>
-        </p:style>
-        <p:txBody>
-          <a:bodyPr rtlCol="0" anchor="ctr"/>
-          <a:lstStyle/>
-          <a:p>
-            <a:pPr algn="ctr"/>
-          </a:p>
-        </p:txBody>
-      </p:sp>
-      <p:sp>
-        <p:nvSpPr>
-          <p:cNvPr id="58" name="Rectangle 57"/>
-          <p:cNvSpPr/>
-          <p:nvPr/>
-        </p:nvSpPr>
-        <p:spPr>
-          <a:xfrm>
-            <a:off x="6255867" y="4724146"/>
-            <a:ext cx="73152" cy="1310894"/>
-          </a:xfrm>
-          <a:prstGeom prst="rect">
-            <a:avLst/>
-          </a:prstGeom>
-          <a:solidFill>
-            <a:srgbClr val="C2562D"/>
-          </a:solidFill>
-          <a:ln>
-            <a:noFill/>
-          </a:ln>
-          <a:effectLst/>
-        </p:spPr>
-        <p:style>
-          <a:lnRef idx="1">
-            <a:schemeClr val="accent1"/>
-          </a:lnRef>
-          <a:fillRef idx="3">
-            <a:schemeClr val="accent1"/>
-          </a:fillRef>
-          <a:effectRef idx="2">
-            <a:schemeClr val="accent1"/>
-          </a:effectRef>
-          <a:fontRef idx="minor">
-            <a:schemeClr val="lt1"/>
-          </a:fontRef>
-        </p:style>
-        <p:txBody>
-          <a:bodyPr rtlCol="0" anchor="ctr"/>
-          <a:lstStyle/>
-          <a:p>
-            <a:pPr algn="ctr"/>
-          </a:p>
-        </p:txBody>
-      </p:sp>
-      <p:sp>
-        <p:nvSpPr>
-          <p:cNvPr id="59" name="TextBox 58"/>
-          <p:cNvSpPr txBox="1"/>
-          <p:nvPr/>
-        </p:nvSpPr>
-        <p:spPr>
-          <a:xfrm>
-            <a:off x="6530187" y="4888738"/>
-            <a:ext cx="4936991" cy="323214"/>
-          </a:xfrm>
-          <a:prstGeom prst="rect">
-            <a:avLst/>
-          </a:prstGeom>
-          <a:noFill/>
-        </p:spPr>
-        <p:txBody>
-          <a:bodyPr wrap="square" lIns="0" rIns="0" tIns="0" bIns="0" anchor="t">
-            <a:spAutoFit/>
-          </a:bodyPr>
-          <a:lstStyle/>
-          <a:p>
-            <a:pPr algn="l">
-              <a:lnSpc>
-                <a:spcPts val="2185"/>
-              </a:lnSpc>
-            </a:pPr>
-            <a:r>
-              <a:rPr sz="1900" b="1">
-                <a:solidFill>
-                  <a:srgbClr val="1B2A4A"/>
-                </a:solidFill>
-                <a:latin typeface="Georgia"/>
-              </a:rPr>
-              <a:t>Jihozlarni tozalash</a:t>
-            </a:r>
-          </a:p>
-        </p:txBody>
-      </p:sp>
-      <p:sp>
-        <p:nvSpPr>
-          <p:cNvPr id="60" name="TextBox 59"/>
-          <p:cNvSpPr txBox="1"/>
-          <p:nvPr/>
-        </p:nvSpPr>
-        <p:spPr>
-          <a:xfrm>
-            <a:off x="6530187" y="5257673"/>
-            <a:ext cx="4936991" cy="574040"/>
-          </a:xfrm>
-          <a:prstGeom prst="rect">
-            <a:avLst/>
-          </a:prstGeom>
-          <a:noFill/>
-        </p:spPr>
-        <p:txBody>
-          <a:bodyPr wrap="square" lIns="0" rIns="0" tIns="0" bIns="0" anchor="t">
-            <a:spAutoFit/>
-          </a:bodyPr>
-          <a:lstStyle/>
-          <a:p>
-            <a:pPr algn="l">
-              <a:lnSpc>
-                <a:spcPts val="2080"/>
-              </a:lnSpc>
-            </a:pPr>
-            <a:r>
-              <a:rPr sz="1600" b="0">
-                <a:solidFill>
-                  <a:srgbClr val="3A4560"/>
-                </a:solidFill>
-                <a:latin typeface="Segoe UI"/>
-              </a:rPr>
-              <a:t>Monitor, klaviatura va sichqoncha faqat o‘chirilgan</a:t>
-            </a:r>
-            <a:br/>
-            <a:r>
-              <a:rPr sz="1600" b="0">
-                <a:solidFill>
-                  <a:srgbClr val="3A4560"/>
-                </a:solidFill>
-                <a:latin typeface="Segoe UI"/>
-              </a:rPr>
-              <a:t>holatda, maxsus salfetkalar bilan artiladi.</a:t>
+              <a:t>Xona ichidagi havo harorati, nisbiy namligi, havo harakati tezligi va issiqlik nurlanishi majmui.</a:t>
             </a:r>
           </a:p>
         </p:txBody>

</xml_diff>